<commit_message>
Presentación final - pequeños fixes
</commit_message>
<xml_diff>
--- a/people_analytics_G6_capacitación.pptx
+++ b/people_analytics_G6_capacitación.pptx
@@ -4567,7 +4567,7 @@
                   <a:srgbClr val="E74C3C"/>
                 </a:solidFill>
               </a:rPr>
-              <a:t>9 / 9</a:t>
+              <a:t>8 / 9</a:t>
             </a:r>
             <a:endParaRPr lang="en-US" sz="900" dirty="0"/>
           </a:p>
@@ -5076,6 +5076,126 @@
           </a:prstGeom>
         </p:spPr>
       </p:pic>
+      <p:sp>
+        <p:nvSpPr>
+          <p:cNvPr id="7" name="Text 3">
+            <a:extLst>
+              <a:ext uri="{FF2B5EF4-FFF2-40B4-BE49-F238E27FC236}">
+                <a16:creationId xmlns:a16="http://schemas.microsoft.com/office/drawing/2014/main" id="{363B22B3-E736-3F34-BEB7-BCFAB2580B1C}"/>
+              </a:ext>
+            </a:extLst>
+          </p:cNvPr>
+          <p:cNvSpPr/>
+          <p:nvPr/>
+        </p:nvSpPr>
+        <p:spPr>
+          <a:xfrm>
+            <a:off x="2931592" y="3139428"/>
+            <a:ext cx="8229600" cy="1371600"/>
+          </a:xfrm>
+          <a:prstGeom prst="rect">
+            <a:avLst/>
+          </a:prstGeom>
+          <a:noFill/>
+          <a:ln/>
+        </p:spPr>
+        <p:txBody>
+          <a:bodyPr wrap="square" rtlCol="0" anchor="ctr"/>
+          <a:lstStyle/>
+          <a:p>
+            <a:pPr marL="0" indent="0" algn="l">
+              <a:buNone/>
+            </a:pPr>
+            <a:r>
+              <a:rPr lang="en-US" sz="3400" b="1" dirty="0" err="1">
+                <a:solidFill>
+                  <a:schemeClr val="bg2">
+                    <a:lumMod val="25000"/>
+                  </a:schemeClr>
+                </a:solidFill>
+              </a:rPr>
+              <a:t>Muchas</a:t>
+            </a:r>
+            <a:r>
+              <a:rPr lang="en-US" sz="3400" b="1" dirty="0">
+                <a:solidFill>
+                  <a:schemeClr val="bg2">
+                    <a:lumMod val="25000"/>
+                  </a:schemeClr>
+                </a:solidFill>
+              </a:rPr>
+              <a:t> gracias </a:t>
+            </a:r>
+            <a:r>
+              <a:rPr lang="en-US" sz="3400" b="1" dirty="0" err="1">
+                <a:solidFill>
+                  <a:schemeClr val="bg2">
+                    <a:lumMod val="25000"/>
+                  </a:schemeClr>
+                </a:solidFill>
+              </a:rPr>
+              <a:t>por</a:t>
+            </a:r>
+            <a:r>
+              <a:rPr lang="en-US" sz="3400" b="1" dirty="0">
+                <a:solidFill>
+                  <a:schemeClr val="bg2">
+                    <a:lumMod val="25000"/>
+                  </a:schemeClr>
+                </a:solidFill>
+              </a:rPr>
+              <a:t> </a:t>
+            </a:r>
+            <a:r>
+              <a:rPr lang="en-US" sz="3400" b="1" dirty="0" err="1">
+                <a:solidFill>
+                  <a:schemeClr val="bg2">
+                    <a:lumMod val="25000"/>
+                  </a:schemeClr>
+                </a:solidFill>
+              </a:rPr>
+              <a:t>su</a:t>
+            </a:r>
+            <a:r>
+              <a:rPr lang="en-US" sz="3400" b="1" dirty="0">
+                <a:solidFill>
+                  <a:schemeClr val="bg2">
+                    <a:lumMod val="25000"/>
+                  </a:schemeClr>
+                </a:solidFill>
+              </a:rPr>
+              <a:t> </a:t>
+            </a:r>
+            <a:r>
+              <a:rPr lang="en-US" sz="3400" b="1" dirty="0" err="1">
+                <a:solidFill>
+                  <a:schemeClr val="bg2">
+                    <a:lumMod val="25000"/>
+                  </a:schemeClr>
+                </a:solidFill>
+              </a:rPr>
+              <a:t>atención</a:t>
+            </a:r>
+            <a:r>
+              <a:rPr lang="en-US" sz="3400" b="1" dirty="0">
+                <a:solidFill>
+                  <a:schemeClr val="bg2">
+                    <a:lumMod val="25000"/>
+                  </a:schemeClr>
+                </a:solidFill>
+              </a:rPr>
+              <a:t>…</a:t>
+            </a:r>
+            <a:endParaRPr lang="en-US" sz="3400" dirty="0">
+              <a:solidFill>
+                <a:schemeClr val="bg2">
+                  <a:lumMod val="25000"/>
+                </a:schemeClr>
+              </a:solidFill>
+            </a:endParaRPr>
+          </a:p>
+        </p:txBody>
+      </p:sp>
     </p:spTree>
     <p:extLst>
       <p:ext uri="{BB962C8B-B14F-4D97-AF65-F5344CB8AC3E}">
@@ -8907,56 +9027,6 @@
       </p:sp>
       <p:sp>
         <p:nvSpPr>
-          <p:cNvPr id="22" name="Text 20"/>
-          <p:cNvSpPr/>
-          <p:nvPr/>
-        </p:nvSpPr>
-        <p:spPr>
-          <a:xfrm>
-            <a:off x="274320" y="4544568"/>
-            <a:ext cx="1371600" cy="411480"/>
-          </a:xfrm>
-          <a:prstGeom prst="rect">
-            <a:avLst/>
-          </a:prstGeom>
-          <a:noFill/>
-          <a:ln/>
-        </p:spPr>
-        <p:txBody>
-          <a:bodyPr wrap="square" lIns="0" tIns="0" rIns="0" bIns="0" rtlCol="0" anchor="ctr"/>
-          <a:lstStyle/>
-          <a:p>
-            <a:pPr marL="0" indent="0" algn="l">
-              <a:buNone/>
-            </a:pPr>
-            <a:r>
-              <a:rPr lang="en-US" sz="800" dirty="0">
-                <a:solidFill>
-                  <a:srgbClr val="777777"/>
-                </a:solidFill>
-              </a:rPr>
-              <a:t>Contexto regulatorio</a:t>
-            </a:r>
-            <a:endParaRPr lang="en-US" sz="800" dirty="0"/>
-          </a:p>
-          <a:p>
-            <a:pPr marL="0" indent="0" algn="l">
-              <a:buNone/>
-            </a:pPr>
-            <a:r>
-              <a:rPr lang="en-US" sz="800" dirty="0">
-                <a:solidFill>
-                  <a:srgbClr val="777777"/>
-                </a:solidFill>
-              </a:rPr>
-              <a:t>y situación actual</a:t>
-            </a:r>
-            <a:endParaRPr lang="en-US" sz="800" dirty="0"/>
-          </a:p>
-        </p:txBody>
-      </p:sp>
-      <p:sp>
-        <p:nvSpPr>
           <p:cNvPr id="23" name="Text 21"/>
           <p:cNvSpPr/>
           <p:nvPr/>
@@ -13317,7 +13387,7 @@
                   <a:srgbClr val="E74C3C"/>
                 </a:solidFill>
               </a:rPr>
-              <a:t>3 / 9</a:t>
+              <a:t>2/ 9</a:t>
             </a:r>
             <a:endParaRPr lang="en-US" sz="800" dirty="0"/>
           </a:p>
@@ -14639,7 +14709,7 @@
                   <a:srgbClr val="E74C3C"/>
                 </a:solidFill>
               </a:rPr>
-              <a:t>4 / 9</a:t>
+              <a:t>3 / 9</a:t>
             </a:r>
             <a:endParaRPr lang="en-US" sz="900" dirty="0"/>
           </a:p>
@@ -15923,12 +15993,20 @@
               <a:buNone/>
             </a:pPr>
             <a:r>
+              <a:rPr lang="en-US" sz="1400" b="1" dirty="0" err="1">
+                <a:solidFill>
+                  <a:srgbClr val="E74C3C"/>
+                </a:solidFill>
+              </a:rPr>
+              <a:t>Hipótesis</a:t>
+            </a:r>
+            <a:r>
               <a:rPr lang="en-US" sz="1400" b="1" dirty="0">
                 <a:solidFill>
                   <a:srgbClr val="E74C3C"/>
                 </a:solidFill>
               </a:rPr>
-              <a:t>El precio no distingue proveedores. La decisión debe basarse </a:t>
+              <a:t>: El precio no distingue proveedores. La decisión debe basarse </a:t>
             </a:r>
             <a:r>
               <a:rPr lang="en-US" sz="1400" b="1" dirty="0" err="1">
@@ -16064,7 +16142,7 @@
                   <a:srgbClr val="E74C3C"/>
                 </a:solidFill>
               </a:rPr>
-              <a:t>5 / 9</a:t>
+              <a:t>4 / 9</a:t>
             </a:r>
             <a:endParaRPr lang="en-US" sz="900" dirty="0"/>
           </a:p>
@@ -17667,7 +17745,7 @@
                   <a:srgbClr val="E74C3C"/>
                 </a:solidFill>
               </a:rPr>
-              <a:t>6 / 9</a:t>
+              <a:t>5/ 9</a:t>
             </a:r>
             <a:endParaRPr lang="en-US" sz="900" dirty="0"/>
           </a:p>
@@ -17901,14 +17979,14 @@
               <a:buNone/>
             </a:pPr>
             <a:r>
-              <a:rPr lang="en-US" sz="2800" b="1" dirty="0">
+              <a:rPr lang="en-US" sz="2400" b="1" dirty="0">
                 <a:solidFill>
                   <a:srgbClr val="1A1A1A"/>
                 </a:solidFill>
               </a:rPr>
               <a:t>EDA y Clustering: segmentación de 5.000 colaboradores en 3 perfiles</a:t>
             </a:r>
-            <a:endParaRPr lang="en-US" sz="2800" dirty="0"/>
+            <a:endParaRPr lang="en-US" sz="2400" dirty="0"/>
           </a:p>
         </p:txBody>
       </p:sp>
@@ -17940,7 +18018,7 @@
           <a:bodyPr/>
           <a:lstStyle/>
           <a:p>
-            <a:endParaRPr lang="es-CL" sz="2400"/>
+            <a:endParaRPr lang="es-CL" sz="2000"/>
           </a:p>
         </p:txBody>
       </p:sp>
@@ -19803,7 +19881,7 @@
                   <a:srgbClr val="E74C3C"/>
                 </a:solidFill>
               </a:rPr>
-              <a:t>7 / 9</a:t>
+              <a:t>6 / 9</a:t>
             </a:r>
             <a:endParaRPr lang="en-US" sz="1000" dirty="0"/>
           </a:p>
@@ -22532,7 +22610,7 @@
                   <a:srgbClr val="E74C3C"/>
                 </a:solidFill>
               </a:rPr>
-              <a:t>8 / 9</a:t>
+              <a:t>7 / 9</a:t>
             </a:r>
             <a:endParaRPr lang="en-US" sz="900" dirty="0"/>
           </a:p>

</xml_diff>